<commit_message>
Agrandit le titre, le sous-titre et les services, et range le pied en grille 2 x 2
Titre 94 px, sous-titre 23 px, « À la cave 71 » 28 px, services 38/31 px.
Pied : adresse | horaires et téléphone / en ligne | QR code avec « Scannez-moi »,
séparés par des filets dorés, sans espace vide. Deux versions et PPTX régénérés.

Co-Authored-By: Claude Opus 5.5 <noreply@anthropic.com>
Claude-Session: https://claude.ai/code/session_01MhDWXdDg6yxkfVQXWRp9UB
</commit_message>
<xml_diff>
--- a/panneau/exports/panneau-cave71-A1-clair-modifiable.pptx
+++ b/panneau/exports/panneau-cave71-A1-clair-modifiable.pptx
@@ -3182,8 +3182,8 @@
         </p:nvSpPr>
         <p:spPr>
           <a:xfrm>
-            <a:off x="0" y="4518232"/>
-            <a:ext cx="21384000" cy="1379612"/>
+            <a:off x="0" y="4449251"/>
+            <a:ext cx="21384000" cy="1621045"/>
           </a:xfrm>
           <a:prstGeom prst="rect">
             <a:avLst/>
@@ -3196,11 +3196,11 @@
           <a:p>
             <a:pPr algn="ctr">
               <a:lnSpc>
-                <a:spcPts val="10863"/>
+                <a:spcPts val="12764"/>
               </a:lnSpc>
             </a:pPr>
             <a:r>
-              <a:rPr sz="10863" b="0" i="1">
+              <a:rPr sz="12764" b="0" i="1">
                 <a:solidFill>
                   <a:srgbClr val="2A1619"/>
                 </a:solidFill>
@@ -3210,7 +3210,7 @@
               <a:t>Vins, spiritueux </a:t>
             </a:r>
             <a:r>
-              <a:rPr sz="10863" b="0" i="1">
+              <a:rPr sz="12764" b="0" i="1">
                 <a:solidFill>
                   <a:srgbClr val="A77A26"/>
                 </a:solidFill>
@@ -3220,7 +3220,7 @@
               <a:t>&amp;</a:t>
             </a:r>
             <a:r>
-              <a:rPr sz="10863" b="0" i="1">
+              <a:rPr sz="12764" b="0" i="1">
                 <a:solidFill>
                   <a:srgbClr val="2A1619"/>
                 </a:solidFill>
@@ -3240,8 +3240,8 @@
         </p:nvSpPr>
         <p:spPr>
           <a:xfrm>
-            <a:off x="0" y="6104787"/>
-            <a:ext cx="21384000" cy="372495"/>
+            <a:off x="0" y="6346219"/>
+            <a:ext cx="21384000" cy="475966"/>
           </a:xfrm>
           <a:prstGeom prst="rect">
             <a:avLst/>
@@ -3254,11 +3254,11 @@
           <a:p>
             <a:pPr algn="ctr">
               <a:lnSpc>
-                <a:spcPts val="2933"/>
+                <a:spcPts val="3747"/>
               </a:lnSpc>
             </a:pPr>
             <a:r>
-              <a:rPr sz="2444" b="1" i="0" spc="815">
+              <a:rPr sz="3123" b="1" i="0" spc="815">
                 <a:solidFill>
                   <a:srgbClr val="7D1530"/>
                 </a:solidFill>
@@ -3278,8 +3278,8 @@
         </p:nvSpPr>
         <p:spPr>
           <a:xfrm>
-            <a:off x="7242967" y="18728245"/>
-            <a:ext cx="6898064" cy="434578"/>
+            <a:off x="6380709" y="18831716"/>
+            <a:ext cx="8622580" cy="579437"/>
           </a:xfrm>
           <a:prstGeom prst="rect">
             <a:avLst/>
@@ -3292,11 +3292,11 @@
           <a:p>
             <a:pPr algn="ctr">
               <a:lnSpc>
-                <a:spcPts val="3421"/>
+                <a:spcPts val="4562"/>
               </a:lnSpc>
             </a:pPr>
             <a:r>
-              <a:rPr sz="2851" b="1" i="0" spc="679">
+              <a:rPr sz="3802" b="1" i="0" spc="815">
                 <a:solidFill>
                   <a:srgbClr val="A77A26"/>
                 </a:solidFill>
@@ -3316,8 +3316,8 @@
         </p:nvSpPr>
         <p:spPr>
           <a:xfrm>
-            <a:off x="2586774" y="19452541"/>
-            <a:ext cx="5173548" cy="1229579"/>
+            <a:off x="2328096" y="19590503"/>
+            <a:ext cx="6208258" cy="1332706"/>
           </a:xfrm>
           <a:prstGeom prst="rect">
             <a:avLst/>
@@ -3330,11 +3330,11 @@
           <a:p>
             <a:pPr algn="l">
               <a:lnSpc>
-                <a:spcPts val="5309"/>
+                <a:spcPts val="5779"/>
               </a:lnSpc>
             </a:pPr>
             <a:r>
-              <a:rPr sz="4616" b="1" i="0">
+              <a:rPr sz="5159" b="1" i="0">
                 <a:solidFill>
                   <a:srgbClr val="2A1619"/>
                 </a:solidFill>
@@ -3347,11 +3347,11 @@
           <a:p>
             <a:pPr algn="l">
               <a:lnSpc>
-                <a:spcPts val="4372"/>
+                <a:spcPts val="4714"/>
               </a:lnSpc>
             </a:pPr>
             <a:r>
-              <a:rPr sz="3802" b="0" i="1">
+              <a:rPr sz="4209" b="0" i="1">
                 <a:solidFill>
                   <a:srgbClr val="7D1530"/>
                 </a:solidFill>
@@ -3371,8 +3371,8 @@
         </p:nvSpPr>
         <p:spPr>
           <a:xfrm>
-            <a:off x="9226161" y="19452541"/>
-            <a:ext cx="5173548" cy="1229579"/>
+            <a:off x="9053709" y="19590503"/>
+            <a:ext cx="6208258" cy="1332706"/>
           </a:xfrm>
           <a:prstGeom prst="rect">
             <a:avLst/>
@@ -3385,11 +3385,11 @@
           <a:p>
             <a:pPr algn="l">
               <a:lnSpc>
-                <a:spcPts val="5309"/>
+                <a:spcPts val="5779"/>
               </a:lnSpc>
             </a:pPr>
             <a:r>
-              <a:rPr sz="4616" b="1" i="0">
+              <a:rPr sz="5159" b="1" i="0">
                 <a:solidFill>
                   <a:srgbClr val="2A1619"/>
                 </a:solidFill>
@@ -3402,11 +3402,11 @@
           <a:p>
             <a:pPr algn="l">
               <a:lnSpc>
-                <a:spcPts val="4372"/>
+                <a:spcPts val="4714"/>
               </a:lnSpc>
             </a:pPr>
             <a:r>
-              <a:rPr sz="3802" b="0" i="1">
+              <a:rPr sz="4209" b="0" i="1">
                 <a:solidFill>
                   <a:srgbClr val="7D1530"/>
                 </a:solidFill>
@@ -3426,8 +3426,8 @@
         </p:nvSpPr>
         <p:spPr>
           <a:xfrm>
-            <a:off x="15865548" y="19452541"/>
-            <a:ext cx="4828645" cy="1229579"/>
+            <a:off x="15951774" y="19590503"/>
+            <a:ext cx="6208258" cy="1332706"/>
           </a:xfrm>
           <a:prstGeom prst="rect">
             <a:avLst/>
@@ -3440,11 +3440,11 @@
           <a:p>
             <a:pPr algn="l">
               <a:lnSpc>
-                <a:spcPts val="5309"/>
+                <a:spcPts val="5779"/>
               </a:lnSpc>
             </a:pPr>
             <a:r>
-              <a:rPr sz="4616" b="1" i="0">
+              <a:rPr sz="5159" b="1" i="0">
                 <a:solidFill>
                   <a:srgbClr val="2A1619"/>
                 </a:solidFill>
@@ -3457,11 +3457,11 @@
           <a:p>
             <a:pPr algn="l">
               <a:lnSpc>
-                <a:spcPts val="4372"/>
+                <a:spcPts val="4714"/>
               </a:lnSpc>
             </a:pPr>
             <a:r>
-              <a:rPr sz="3802" b="0" i="1">
+              <a:rPr sz="4209" b="0" i="1">
                 <a:solidFill>
                   <a:srgbClr val="7D1530"/>
                 </a:solidFill>
@@ -3481,8 +3481,8 @@
         </p:nvSpPr>
         <p:spPr>
           <a:xfrm>
-            <a:off x="5915090" y="21039096"/>
-            <a:ext cx="5173548" cy="1229579"/>
+            <a:off x="4483741" y="21211548"/>
+            <a:ext cx="6208258" cy="1332706"/>
           </a:xfrm>
           <a:prstGeom prst="rect">
             <a:avLst/>
@@ -3495,11 +3495,11 @@
           <a:p>
             <a:pPr algn="l">
               <a:lnSpc>
-                <a:spcPts val="5309"/>
+                <a:spcPts val="5779"/>
               </a:lnSpc>
             </a:pPr>
             <a:r>
-              <a:rPr sz="4616" b="1" i="0">
+              <a:rPr sz="5159" b="1" i="0">
                 <a:solidFill>
                   <a:srgbClr val="2A1619"/>
                 </a:solidFill>
@@ -3512,11 +3512,11 @@
           <a:p>
             <a:pPr algn="l">
               <a:lnSpc>
-                <a:spcPts val="4372"/>
+                <a:spcPts val="4714"/>
               </a:lnSpc>
             </a:pPr>
             <a:r>
-              <a:rPr sz="3802" b="0" i="1">
+              <a:rPr sz="4209" b="0" i="1">
                 <a:solidFill>
                   <a:srgbClr val="7D1530"/>
                 </a:solidFill>
@@ -3536,8 +3536,8 @@
         </p:nvSpPr>
         <p:spPr>
           <a:xfrm>
-            <a:off x="12554477" y="21039096"/>
-            <a:ext cx="5863354" cy="1229579"/>
+            <a:off x="12502741" y="21211548"/>
+            <a:ext cx="6208258" cy="1332706"/>
           </a:xfrm>
           <a:prstGeom prst="rect">
             <a:avLst/>
@@ -3550,11 +3550,11 @@
           <a:p>
             <a:pPr algn="l">
               <a:lnSpc>
-                <a:spcPts val="5309"/>
+                <a:spcPts val="5779"/>
               </a:lnSpc>
             </a:pPr>
             <a:r>
-              <a:rPr sz="4616" b="1" i="0">
+              <a:rPr sz="5159" b="1" i="0">
                 <a:solidFill>
                   <a:srgbClr val="2A1619"/>
                 </a:solidFill>
@@ -3567,11 +3567,11 @@
           <a:p>
             <a:pPr algn="l">
               <a:lnSpc>
-                <a:spcPts val="4372"/>
+                <a:spcPts val="4714"/>
               </a:lnSpc>
             </a:pPr>
             <a:r>
-              <a:rPr sz="3802" b="0" i="1">
+              <a:rPr sz="4209" b="0" i="1">
                 <a:solidFill>
                   <a:srgbClr val="7D1530"/>
                 </a:solidFill>
@@ -3591,8 +3591,8 @@
         </p:nvSpPr>
         <p:spPr>
           <a:xfrm>
-            <a:off x="1207161" y="23315458"/>
-            <a:ext cx="8967483" cy="393189"/>
+            <a:off x="1207161" y="23384438"/>
+            <a:ext cx="9312387" cy="393189"/>
           </a:xfrm>
           <a:prstGeom prst="rect">
             <a:avLst/>
@@ -3629,8 +3629,8 @@
         </p:nvSpPr>
         <p:spPr>
           <a:xfrm>
-            <a:off x="1207161" y="23867303"/>
-            <a:ext cx="8967483" cy="1389960"/>
+            <a:off x="1207161" y="23901793"/>
+            <a:ext cx="9312387" cy="1336500"/>
           </a:xfrm>
           <a:prstGeom prst="rect">
             <a:avLst/>
@@ -3643,7 +3643,7 @@
           <a:p>
             <a:pPr algn="l">
               <a:lnSpc>
-                <a:spcPts val="5472"/>
+                <a:spcPts val="5261"/>
               </a:lnSpc>
             </a:pPr>
             <a:r>
@@ -3660,7 +3660,7 @@
           <a:p>
             <a:pPr algn="l">
               <a:lnSpc>
-                <a:spcPts val="5472"/>
+                <a:spcPts val="5261"/>
               </a:lnSpc>
             </a:pPr>
             <a:r>
@@ -3684,8 +3684,8 @@
         </p:nvSpPr>
         <p:spPr>
           <a:xfrm>
-            <a:off x="1207161" y="25350387"/>
-            <a:ext cx="8967483" cy="413883"/>
+            <a:off x="1207161" y="25315896"/>
+            <a:ext cx="9312387" cy="413883"/>
           </a:xfrm>
           <a:prstGeom prst="rect">
             <a:avLst/>
@@ -3722,8 +3722,8 @@
         </p:nvSpPr>
         <p:spPr>
           <a:xfrm>
-            <a:off x="10692000" y="23315458"/>
-            <a:ext cx="9484838" cy="393189"/>
+            <a:off x="11468032" y="23384438"/>
+            <a:ext cx="8795032" cy="393189"/>
           </a:xfrm>
           <a:prstGeom prst="rect">
             <a:avLst/>
@@ -3734,7 +3734,7 @@
           <a:bodyPr wrap="none" anchor="t" lIns="0" rIns="0" tIns="0" bIns="0"/>
           <a:lstStyle/>
           <a:p>
-            <a:pPr algn="r">
+            <a:pPr algn="l">
               <a:lnSpc>
                 <a:spcPts val="3095"/>
               </a:lnSpc>
@@ -3760,8 +3760,8 @@
         </p:nvSpPr>
         <p:spPr>
           <a:xfrm>
-            <a:off x="10692000" y="23867303"/>
-            <a:ext cx="9484838" cy="641519"/>
+            <a:off x="11468032" y="23901793"/>
+            <a:ext cx="8795032" cy="641519"/>
           </a:xfrm>
           <a:prstGeom prst="rect">
             <a:avLst/>
@@ -3772,7 +3772,7 @@
           <a:bodyPr wrap="none" anchor="t" lIns="0" rIns="0" tIns="0" bIns="0"/>
           <a:lstStyle/>
           <a:p>
-            <a:pPr algn="r">
+            <a:pPr algn="l">
               <a:lnSpc>
                 <a:spcPts val="5051"/>
               </a:lnSpc>
@@ -3818,8 +3818,8 @@
         </p:nvSpPr>
         <p:spPr>
           <a:xfrm>
-            <a:off x="10692000" y="24626090"/>
-            <a:ext cx="9484838" cy="1034709"/>
+            <a:off x="11468032" y="24626090"/>
+            <a:ext cx="8795032" cy="993321"/>
           </a:xfrm>
           <a:prstGeom prst="rect">
             <a:avLst/>
@@ -3830,13 +3830,13 @@
           <a:bodyPr wrap="none" anchor="t" lIns="0" rIns="0" tIns="0" bIns="0"/>
           <a:lstStyle/>
           <a:p>
-            <a:pPr algn="r">
+            <a:pPr algn="l">
               <a:lnSpc>
-                <a:spcPts val="8147"/>
+                <a:spcPts val="7821"/>
               </a:lnSpc>
             </a:pPr>
             <a:r>
-              <a:rPr sz="6789" b="1" i="0" spc="272">
+              <a:rPr sz="6517" b="1" i="0" spc="272">
                 <a:solidFill>
                   <a:srgbClr val="2A1619"/>
                 </a:solidFill>
@@ -3856,8 +3856,8 @@
         </p:nvSpPr>
         <p:spPr>
           <a:xfrm>
-            <a:off x="1207161" y="26557548"/>
-            <a:ext cx="10347096" cy="393189"/>
+            <a:off x="1207161" y="26316116"/>
+            <a:ext cx="9312387" cy="393189"/>
           </a:xfrm>
           <a:prstGeom prst="rect">
             <a:avLst/>
@@ -3894,8 +3894,8 @@
         </p:nvSpPr>
         <p:spPr>
           <a:xfrm>
-            <a:off x="1207161" y="27074903"/>
-            <a:ext cx="15520645" cy="1275279"/>
+            <a:off x="1207161" y="26833470"/>
+            <a:ext cx="9312387" cy="1676229"/>
           </a:xfrm>
           <a:prstGeom prst="rect">
             <a:avLst/>
@@ -3908,7 +3908,7 @@
           <a:p>
             <a:pPr algn="l">
               <a:lnSpc>
-                <a:spcPts val="5906"/>
+                <a:spcPts val="5499"/>
               </a:lnSpc>
             </a:pPr>
             <a:r>
@@ -3925,7 +3925,7 @@
           <a:p>
             <a:pPr algn="l">
               <a:lnSpc>
-                <a:spcPts val="4134"/>
+                <a:spcPts val="3849"/>
               </a:lnSpc>
             </a:pPr>
             <a:r>
@@ -3936,14 +3936,103 @@
                 <a:latin typeface="Montserrat"/>
                 <a:cs typeface="Montserrat"/>
               </a:rPr>
-              <a:t>contact.cave71@gmail.com  ·  Facebook : Cave 71</a:t>
-            </a:r>
-          </a:p>
-        </p:txBody>
-      </p:sp>
-      <p:sp>
-        <p:nvSpPr>
-          <p:cNvPr id="21" name="mention-legale"/>
+              <a:t>contact.cave71@gmail.com</a:t>
+            </a:r>
+          </a:p>
+          <a:p>
+            <a:pPr algn="l">
+              <a:lnSpc>
+                <a:spcPts val="3849"/>
+              </a:lnSpc>
+            </a:pPr>
+            <a:r>
+              <a:rPr sz="2851" b="0" i="0">
+                <a:solidFill>
+                  <a:srgbClr val="2A1619"/>
+                </a:solidFill>
+                <a:latin typeface="Montserrat"/>
+                <a:cs typeface="Montserrat"/>
+              </a:rPr>
+              <a:t>Facebook : Cave 71</a:t>
+            </a:r>
+          </a:p>
+        </p:txBody>
+      </p:sp>
+      <p:sp>
+        <p:nvSpPr>
+          <p:cNvPr id="21" name="qr-texte"/>
+          <p:cNvSpPr txBox="1"/>
+          <p:nvPr/>
+        </p:nvSpPr>
+        <p:spPr>
+          <a:xfrm>
+            <a:off x="14175522" y="26454077"/>
+            <a:ext cx="6035806" cy="1676229"/>
+          </a:xfrm>
+          <a:prstGeom prst="rect">
+            <a:avLst/>
+          </a:prstGeom>
+          <a:noFill/>
+        </p:spPr>
+        <p:txBody>
+          <a:bodyPr wrap="none" anchor="t" lIns="0" rIns="0" tIns="0" bIns="0"/>
+          <a:lstStyle/>
+          <a:p>
+            <a:pPr algn="l">
+              <a:lnSpc>
+                <a:spcPts val="3095"/>
+              </a:lnSpc>
+            </a:pPr>
+            <a:r>
+              <a:rPr sz="2579" b="1" i="0" spc="679">
+                <a:solidFill>
+                  <a:srgbClr val="A77A26"/>
+                </a:solidFill>
+                <a:latin typeface="Montserrat"/>
+                <a:cs typeface="Montserrat"/>
+              </a:rPr>
+              <a:t>SCANNEZ-MOI</a:t>
+            </a:r>
+          </a:p>
+          <a:p>
+            <a:pPr algn="l">
+              <a:lnSpc>
+                <a:spcPts val="5051"/>
+              </a:lnSpc>
+            </a:pPr>
+            <a:r>
+              <a:rPr sz="4209" b="0" i="1">
+                <a:solidFill>
+                  <a:srgbClr val="2A1619"/>
+                </a:solidFill>
+                <a:latin typeface="Cormorant Garamond"/>
+                <a:cs typeface="Cormorant Garamond"/>
+              </a:rPr>
+              <a:t>Découvrez nos vins</a:t>
+            </a:r>
+          </a:p>
+          <a:p>
+            <a:pPr algn="l">
+              <a:lnSpc>
+                <a:spcPts val="5051"/>
+              </a:lnSpc>
+            </a:pPr>
+            <a:r>
+              <a:rPr sz="4209" b="0" i="1">
+                <a:solidFill>
+                  <a:srgbClr val="7D1530"/>
+                </a:solidFill>
+                <a:latin typeface="Cormorant Garamond"/>
+                <a:cs typeface="Cormorant Garamond"/>
+              </a:rPr>
+              <a:t>&amp; commandez en ligne</a:t>
+            </a:r>
+          </a:p>
+        </p:txBody>
+      </p:sp>
+      <p:sp>
+        <p:nvSpPr>
+          <p:cNvPr id="22" name="mention-legale"/>
           <p:cNvSpPr txBox="1"/>
           <p:nvPr/>
         </p:nvSpPr>

</xml_diff>

<commit_message>
Allège les textes de l'affiche
Services en 5 colonnes (icône + deux lignes courtes), graisses réduites, titres de rubriques
plus discrets, coordonnées secondaires (e-mail, Facebook) en ton adouci : seul le téléphone
reste en gras. Deux versions et PPTX régénérés.

Co-Authored-By: Claude Opus 5.5 <noreply@anthropic.com>
Claude-Session: https://claude.ai/code/session_01MhDWXdDg6yxkfVQXWRp9UB
</commit_message>
<xml_diff>
--- a/panneau/exports/panneau-cave71-A1-clair-modifiable.pptx
+++ b/panneau/exports/panneau-cave71-A1-clair-modifiable.pptx
@@ -3145,7 +3145,7 @@
         <p:spPr>
           <a:xfrm>
             <a:off x="0" y="1034709"/>
-            <a:ext cx="21384000" cy="393189"/>
+            <a:ext cx="21384000" cy="351801"/>
           </a:xfrm>
           <a:prstGeom prst="rect">
             <a:avLst/>
@@ -3158,11 +3158,11 @@
           <a:p>
             <a:pPr algn="ctr">
               <a:lnSpc>
-                <a:spcPts val="3095"/>
+                <a:spcPts val="2770"/>
               </a:lnSpc>
             </a:pPr>
             <a:r>
-              <a:rPr sz="2579" b="1" i="0" spc="679">
+              <a:rPr sz="2308" b="0" i="0" spc="679">
                 <a:solidFill>
                   <a:srgbClr val="A77A26"/>
                 </a:solidFill>
@@ -3258,7 +3258,7 @@
               </a:lnSpc>
             </a:pPr>
             <a:r>
-              <a:rPr sz="3123" b="1" i="0" spc="815">
+              <a:rPr sz="3123" b="0" i="0" spc="815">
                 <a:solidFill>
                   <a:srgbClr val="7D1530"/>
                 </a:solidFill>
@@ -3278,8 +3278,8 @@
         </p:nvSpPr>
         <p:spPr>
           <a:xfrm>
-            <a:off x="6380709" y="18831716"/>
-            <a:ext cx="8622580" cy="579437"/>
+            <a:off x="6380709" y="18866206"/>
+            <a:ext cx="8622580" cy="455272"/>
           </a:xfrm>
           <a:prstGeom prst="rect">
             <a:avLst/>
@@ -3292,11 +3292,11 @@
           <a:p>
             <a:pPr algn="ctr">
               <a:lnSpc>
-                <a:spcPts val="4562"/>
+                <a:spcPts val="3584"/>
               </a:lnSpc>
             </a:pPr>
             <a:r>
-              <a:rPr sz="3802" b="1" i="0" spc="815">
+              <a:rPr sz="2987" b="1" i="0" spc="815">
                 <a:solidFill>
                   <a:srgbClr val="A77A26"/>
                 </a:solidFill>
@@ -3316,8 +3316,8 @@
         </p:nvSpPr>
         <p:spPr>
           <a:xfrm>
-            <a:off x="2328096" y="19590503"/>
-            <a:ext cx="6208258" cy="1332706"/>
+            <a:off x="1207161" y="20935625"/>
+            <a:ext cx="3793935" cy="1090756"/>
           </a:xfrm>
           <a:prstGeom prst="rect">
             <a:avLst/>
@@ -3328,13 +3328,13 @@
           <a:bodyPr wrap="none" anchor="t" lIns="0" rIns="0" tIns="0" bIns="0"/>
           <a:lstStyle/>
           <a:p>
-            <a:pPr algn="l">
+            <a:pPr algn="ctr">
               <a:lnSpc>
-                <a:spcPts val="5779"/>
+                <a:spcPts val="4684"/>
               </a:lnSpc>
             </a:pPr>
             <a:r>
-              <a:rPr sz="5159" b="1" i="0">
+              <a:rPr sz="4073" b="1" i="0">
                 <a:solidFill>
                   <a:srgbClr val="2A1619"/>
                 </a:solidFill>
@@ -3345,13 +3345,13 @@
             </a:r>
           </a:p>
           <a:p>
-            <a:pPr algn="l">
+            <a:pPr algn="ctr">
               <a:lnSpc>
-                <a:spcPts val="4714"/>
+                <a:spcPts val="3903"/>
               </a:lnSpc>
             </a:pPr>
             <a:r>
-              <a:rPr sz="4209" b="0" i="1">
+              <a:rPr sz="3394" b="0" i="1">
                 <a:solidFill>
                   <a:srgbClr val="7D1530"/>
                 </a:solidFill>
@@ -3371,8 +3371,8 @@
         </p:nvSpPr>
         <p:spPr>
           <a:xfrm>
-            <a:off x="9053709" y="19590503"/>
-            <a:ext cx="6208258" cy="1332706"/>
+            <a:off x="5001096" y="20935625"/>
+            <a:ext cx="3793935" cy="1090756"/>
           </a:xfrm>
           <a:prstGeom prst="rect">
             <a:avLst/>
@@ -3383,37 +3383,37 @@
           <a:bodyPr wrap="none" anchor="t" lIns="0" rIns="0" tIns="0" bIns="0"/>
           <a:lstStyle/>
           <a:p>
-            <a:pPr algn="l">
+            <a:pPr algn="ctr">
               <a:lnSpc>
-                <a:spcPts val="5779"/>
+                <a:spcPts val="4684"/>
               </a:lnSpc>
             </a:pPr>
             <a:r>
-              <a:rPr sz="5159" b="1" i="0">
+              <a:rPr sz="4073" b="1" i="0">
                 <a:solidFill>
                   <a:srgbClr val="2A1619"/>
                 </a:solidFill>
                 <a:latin typeface="Cormorant Garamond"/>
                 <a:cs typeface="Cormorant Garamond"/>
               </a:rPr>
-              <a:t>Soirées œnologiques</a:t>
-            </a:r>
-          </a:p>
-          <a:p>
-            <a:pPr algn="l">
+              <a:t>Soirées</a:t>
+            </a:r>
+          </a:p>
+          <a:p>
+            <a:pPr algn="ctr">
               <a:lnSpc>
-                <a:spcPts val="4714"/>
+                <a:spcPts val="3903"/>
               </a:lnSpc>
             </a:pPr>
             <a:r>
-              <a:rPr sz="4209" b="0" i="1">
+              <a:rPr sz="3394" b="0" i="1">
                 <a:solidFill>
                   <a:srgbClr val="7D1530"/>
                 </a:solidFill>
                 <a:latin typeface="Cormorant Garamond"/>
                 <a:cs typeface="Cormorant Garamond"/>
               </a:rPr>
-              <a:t>&amp; découvertes</a:t>
+              <a:t>œnologiques</a:t>
             </a:r>
           </a:p>
         </p:txBody>
@@ -3426,8 +3426,8 @@
         </p:nvSpPr>
         <p:spPr>
           <a:xfrm>
-            <a:off x="15951774" y="19590503"/>
-            <a:ext cx="6208258" cy="1332706"/>
+            <a:off x="8795032" y="20935625"/>
+            <a:ext cx="3793935" cy="1090756"/>
           </a:xfrm>
           <a:prstGeom prst="rect">
             <a:avLst/>
@@ -3438,13 +3438,13 @@
           <a:bodyPr wrap="none" anchor="t" lIns="0" rIns="0" tIns="0" bIns="0"/>
           <a:lstStyle/>
           <a:p>
-            <a:pPr algn="l">
+            <a:pPr algn="ctr">
               <a:lnSpc>
-                <a:spcPts val="5779"/>
+                <a:spcPts val="4684"/>
               </a:lnSpc>
             </a:pPr>
             <a:r>
-              <a:rPr sz="5159" b="1" i="0">
+              <a:rPr sz="4073" b="1" i="0">
                 <a:solidFill>
                   <a:srgbClr val="2A1619"/>
                 </a:solidFill>
@@ -3455,13 +3455,13 @@
             </a:r>
           </a:p>
           <a:p>
-            <a:pPr algn="l">
+            <a:pPr algn="ctr">
               <a:lnSpc>
-                <a:spcPts val="4714"/>
+                <a:spcPts val="3903"/>
               </a:lnSpc>
             </a:pPr>
             <a:r>
-              <a:rPr sz="4209" b="0" i="1">
+              <a:rPr sz="3394" b="0" i="1">
                 <a:solidFill>
                   <a:srgbClr val="7D1530"/>
                 </a:solidFill>
@@ -3481,8 +3481,8 @@
         </p:nvSpPr>
         <p:spPr>
           <a:xfrm>
-            <a:off x="4483741" y="21211548"/>
-            <a:ext cx="6208258" cy="1332706"/>
+            <a:off x="12588967" y="20935625"/>
+            <a:ext cx="3793935" cy="1090756"/>
           </a:xfrm>
           <a:prstGeom prst="rect">
             <a:avLst/>
@@ -3493,37 +3493,37 @@
           <a:bodyPr wrap="none" anchor="t" lIns="0" rIns="0" tIns="0" bIns="0"/>
           <a:lstStyle/>
           <a:p>
-            <a:pPr algn="l">
+            <a:pPr algn="ctr">
               <a:lnSpc>
-                <a:spcPts val="5779"/>
+                <a:spcPts val="4684"/>
               </a:lnSpc>
             </a:pPr>
             <a:r>
-              <a:rPr sz="5159" b="1" i="0">
+              <a:rPr sz="4073" b="1" i="0">
                 <a:solidFill>
                   <a:srgbClr val="2A1619"/>
                 </a:solidFill>
                 <a:latin typeface="Cormorant Garamond"/>
                 <a:cs typeface="Cormorant Garamond"/>
               </a:rPr>
-              <a:t>Conseil &amp; élaboration</a:t>
-            </a:r>
-          </a:p>
-          <a:p>
-            <a:pPr algn="l">
+              <a:t>Carte des vins</a:t>
+            </a:r>
+          </a:p>
+          <a:p>
+            <a:pPr algn="ctr">
               <a:lnSpc>
-                <a:spcPts val="4714"/>
+                <a:spcPts val="3903"/>
               </a:lnSpc>
             </a:pPr>
             <a:r>
-              <a:rPr sz="4209" b="0" i="1">
+              <a:rPr sz="3394" b="0" i="1">
                 <a:solidFill>
                   <a:srgbClr val="7D1530"/>
                 </a:solidFill>
                 <a:latin typeface="Cormorant Garamond"/>
                 <a:cs typeface="Cormorant Garamond"/>
               </a:rPr>
-              <a:t>de votre carte des vins</a:t>
+              <a:t>pour les pros</a:t>
             </a:r>
           </a:p>
         </p:txBody>
@@ -3536,8 +3536,8 @@
         </p:nvSpPr>
         <p:spPr>
           <a:xfrm>
-            <a:off x="12502741" y="21211548"/>
-            <a:ext cx="6208258" cy="1332706"/>
+            <a:off x="16382903" y="20935625"/>
+            <a:ext cx="3793935" cy="1090756"/>
           </a:xfrm>
           <a:prstGeom prst="rect">
             <a:avLst/>
@@ -3548,37 +3548,37 @@
           <a:bodyPr wrap="none" anchor="t" lIns="0" rIns="0" tIns="0" bIns="0"/>
           <a:lstStyle/>
           <a:p>
-            <a:pPr algn="l">
+            <a:pPr algn="ctr">
               <a:lnSpc>
-                <a:spcPts val="5779"/>
+                <a:spcPts val="4684"/>
               </a:lnSpc>
             </a:pPr>
             <a:r>
-              <a:rPr sz="5159" b="1" i="0">
+              <a:rPr sz="4073" b="1" i="0">
                 <a:solidFill>
                   <a:srgbClr val="2A1619"/>
                 </a:solidFill>
                 <a:latin typeface="Cormorant Garamond"/>
                 <a:cs typeface="Cormorant Garamond"/>
               </a:rPr>
-              <a:t>Célébrations, mariages</a:t>
-            </a:r>
-          </a:p>
-          <a:p>
-            <a:pPr algn="l">
+              <a:t>Célébrations</a:t>
+            </a:r>
+          </a:p>
+          <a:p>
+            <a:pPr algn="ctr">
               <a:lnSpc>
-                <a:spcPts val="4714"/>
+                <a:spcPts val="3903"/>
               </a:lnSpc>
             </a:pPr>
             <a:r>
-              <a:rPr sz="4209" b="0" i="1">
+              <a:rPr sz="3394" b="0" i="1">
                 <a:solidFill>
                   <a:srgbClr val="7D1530"/>
                 </a:solidFill>
                 <a:latin typeface="Cormorant Garamond"/>
                 <a:cs typeface="Cormorant Garamond"/>
               </a:rPr>
-              <a:t>&amp; événementiel</a:t>
+              <a:t>&amp; mariages</a:t>
             </a:r>
           </a:p>
         </p:txBody>
@@ -3592,7 +3592,7 @@
         <p:spPr>
           <a:xfrm>
             <a:off x="1207161" y="23384438"/>
-            <a:ext cx="9312387" cy="393189"/>
+            <a:ext cx="9312387" cy="331107"/>
           </a:xfrm>
           <a:prstGeom prst="rect">
             <a:avLst/>
@@ -3605,11 +3605,11 @@
           <a:p>
             <a:pPr algn="l">
               <a:lnSpc>
-                <a:spcPts val="3095"/>
+                <a:spcPts val="2607"/>
               </a:lnSpc>
             </a:pPr>
             <a:r>
-              <a:rPr sz="2579" b="1" i="0" spc="679">
+              <a:rPr sz="2172" b="1" i="0" spc="543">
                 <a:solidFill>
                   <a:srgbClr val="A77A26"/>
                 </a:solidFill>
@@ -3629,8 +3629,8 @@
         </p:nvSpPr>
         <p:spPr>
           <a:xfrm>
-            <a:off x="1207161" y="23901793"/>
-            <a:ext cx="9312387" cy="1336500"/>
+            <a:off x="1207161" y="23867303"/>
+            <a:ext cx="9312387" cy="1164048"/>
           </a:xfrm>
           <a:prstGeom prst="rect">
             <a:avLst/>
@@ -3643,11 +3643,11 @@
           <a:p>
             <a:pPr algn="l">
               <a:lnSpc>
-                <a:spcPts val="5261"/>
+                <a:spcPts val="4582"/>
               </a:lnSpc>
             </a:pPr>
             <a:r>
-              <a:rPr sz="4209" b="1" i="0">
+              <a:rPr sz="3666" b="0" i="0">
                 <a:solidFill>
                   <a:srgbClr val="2A1619"/>
                 </a:solidFill>
@@ -3660,11 +3660,11 @@
           <a:p>
             <a:pPr algn="l">
               <a:lnSpc>
-                <a:spcPts val="5261"/>
+                <a:spcPts val="4582"/>
               </a:lnSpc>
             </a:pPr>
             <a:r>
-              <a:rPr sz="4209" b="1" i="0">
+              <a:rPr sz="3666" b="0" i="0">
                 <a:solidFill>
                   <a:srgbClr val="2A1619"/>
                 </a:solidFill>
@@ -3684,8 +3684,8 @@
         </p:nvSpPr>
         <p:spPr>
           <a:xfrm>
-            <a:off x="1207161" y="25315896"/>
-            <a:ext cx="9312387" cy="413883"/>
+            <a:off x="1207161" y="25212425"/>
+            <a:ext cx="9312387" cy="351801"/>
           </a:xfrm>
           <a:prstGeom prst="rect">
             <a:avLst/>
@@ -3698,11 +3698,11 @@
           <a:p>
             <a:pPr algn="l">
               <a:lnSpc>
-                <a:spcPts val="3258"/>
+                <a:spcPts val="2770"/>
               </a:lnSpc>
             </a:pPr>
             <a:r>
-              <a:rPr sz="2715" b="0" i="0">
+              <a:rPr sz="2308" b="0" i="0">
                 <a:solidFill>
                   <a:srgbClr val="7D1530"/>
                 </a:solidFill>
@@ -3723,7 +3723,7 @@
         <p:spPr>
           <a:xfrm>
             <a:off x="11468032" y="23384438"/>
-            <a:ext cx="8795032" cy="393189"/>
+            <a:ext cx="8795032" cy="331107"/>
           </a:xfrm>
           <a:prstGeom prst="rect">
             <a:avLst/>
@@ -3736,11 +3736,11 @@
           <a:p>
             <a:pPr algn="l">
               <a:lnSpc>
-                <a:spcPts val="3095"/>
+                <a:spcPts val="2607"/>
               </a:lnSpc>
             </a:pPr>
             <a:r>
-              <a:rPr sz="2579" b="1" i="0" spc="679">
+              <a:rPr sz="2172" b="1" i="0" spc="543">
                 <a:solidFill>
                   <a:srgbClr val="A77A26"/>
                 </a:solidFill>
@@ -3760,8 +3760,8 @@
         </p:nvSpPr>
         <p:spPr>
           <a:xfrm>
-            <a:off x="11468032" y="23901793"/>
-            <a:ext cx="8795032" cy="641519"/>
+            <a:off x="11468032" y="23867303"/>
+            <a:ext cx="8795032" cy="558743"/>
           </a:xfrm>
           <a:prstGeom prst="rect">
             <a:avLst/>
@@ -3774,11 +3774,11 @@
           <a:p>
             <a:pPr algn="l">
               <a:lnSpc>
-                <a:spcPts val="5051"/>
+                <a:spcPts val="4399"/>
               </a:lnSpc>
             </a:pPr>
             <a:r>
-              <a:rPr sz="4209" b="1" i="0">
+              <a:rPr sz="3666" b="0" i="0">
                 <a:solidFill>
                   <a:srgbClr val="2A1619"/>
                 </a:solidFill>
@@ -3788,7 +3788,7 @@
               <a:t>10h – 13h </a:t>
             </a:r>
             <a:r>
-              <a:rPr sz="4209" b="1" i="0">
+              <a:rPr sz="3666" b="0" i="0">
                 <a:solidFill>
                   <a:srgbClr val="A77A26"/>
                 </a:solidFill>
@@ -3798,7 +3798,7 @@
               <a:t>·</a:t>
             </a:r>
             <a:r>
-              <a:rPr sz="4209" b="1" i="0">
+              <a:rPr sz="3666" b="0" i="0">
                 <a:solidFill>
                   <a:srgbClr val="2A1619"/>
                 </a:solidFill>
@@ -3818,8 +3818,8 @@
         </p:nvSpPr>
         <p:spPr>
           <a:xfrm>
-            <a:off x="11468032" y="24626090"/>
-            <a:ext cx="8795032" cy="993321"/>
+            <a:off x="11468032" y="24557109"/>
+            <a:ext cx="8795032" cy="910544"/>
           </a:xfrm>
           <a:prstGeom prst="rect">
             <a:avLst/>
@@ -3832,11 +3832,11 @@
           <a:p>
             <a:pPr algn="l">
               <a:lnSpc>
-                <a:spcPts val="7821"/>
+                <a:spcPts val="7169"/>
               </a:lnSpc>
             </a:pPr>
             <a:r>
-              <a:rPr sz="6517" b="1" i="0" spc="272">
+              <a:rPr sz="5974" b="1" i="0" spc="204">
                 <a:solidFill>
                   <a:srgbClr val="2A1619"/>
                 </a:solidFill>
@@ -3857,7 +3857,7 @@
         <p:spPr>
           <a:xfrm>
             <a:off x="1207161" y="26316116"/>
-            <a:ext cx="9312387" cy="393189"/>
+            <a:ext cx="9312387" cy="331107"/>
           </a:xfrm>
           <a:prstGeom prst="rect">
             <a:avLst/>
@@ -3870,11 +3870,11 @@
           <a:p>
             <a:pPr algn="l">
               <a:lnSpc>
-                <a:spcPts val="3095"/>
+                <a:spcPts val="2607"/>
               </a:lnSpc>
             </a:pPr>
             <a:r>
-              <a:rPr sz="2579" b="1" i="0" spc="679">
+              <a:rPr sz="2172" b="1" i="0" spc="543">
                 <a:solidFill>
                   <a:srgbClr val="A77A26"/>
                 </a:solidFill>
@@ -3894,8 +3894,8 @@
         </p:nvSpPr>
         <p:spPr>
           <a:xfrm>
-            <a:off x="1207161" y="26833470"/>
-            <a:ext cx="9312387" cy="1676229"/>
+            <a:off x="1207161" y="26798980"/>
+            <a:ext cx="9312387" cy="1496880"/>
           </a:xfrm>
           <a:prstGeom prst="rect">
             <a:avLst/>
@@ -3908,11 +3908,11 @@
           <a:p>
             <a:pPr algn="l">
               <a:lnSpc>
-                <a:spcPts val="5499"/>
+                <a:spcPts val="4942"/>
               </a:lnSpc>
             </a:pPr>
             <a:r>
-              <a:rPr sz="4073" b="1" i="0">
+              <a:rPr sz="3530" b="0" i="0">
                 <a:solidFill>
                   <a:srgbClr val="2A1619"/>
                 </a:solidFill>
@@ -3925,13 +3925,13 @@
           <a:p>
             <a:pPr algn="l">
               <a:lnSpc>
-                <a:spcPts val="3849"/>
+                <a:spcPts val="3421"/>
               </a:lnSpc>
             </a:pPr>
             <a:r>
-              <a:rPr sz="2851" b="0" i="0">
-                <a:solidFill>
-                  <a:srgbClr val="2A1619"/>
+              <a:rPr sz="2444" b="0" i="0">
+                <a:solidFill>
+                  <a:srgbClr val="5E4E4D"/>
                 </a:solidFill>
                 <a:latin typeface="Montserrat"/>
                 <a:cs typeface="Montserrat"/>
@@ -3942,13 +3942,13 @@
           <a:p>
             <a:pPr algn="l">
               <a:lnSpc>
-                <a:spcPts val="3849"/>
+                <a:spcPts val="3421"/>
               </a:lnSpc>
             </a:pPr>
             <a:r>
-              <a:rPr sz="2851" b="0" i="0">
-                <a:solidFill>
-                  <a:srgbClr val="2A1619"/>
+              <a:rPr sz="2444" b="0" i="0">
+                <a:solidFill>
+                  <a:srgbClr val="5E4E4D"/>
                 </a:solidFill>
                 <a:latin typeface="Montserrat"/>
                 <a:cs typeface="Montserrat"/>
@@ -3967,7 +3967,7 @@
         <p:spPr>
           <a:xfrm>
             <a:off x="14175522" y="26454077"/>
-            <a:ext cx="6035806" cy="1676229"/>
+            <a:ext cx="6035806" cy="1489981"/>
           </a:xfrm>
           <a:prstGeom prst="rect">
             <a:avLst/>
@@ -3980,11 +3980,11 @@
           <a:p>
             <a:pPr algn="l">
               <a:lnSpc>
-                <a:spcPts val="3095"/>
+                <a:spcPts val="2607"/>
               </a:lnSpc>
             </a:pPr>
             <a:r>
-              <a:rPr sz="2579" b="1" i="0" spc="679">
+              <a:rPr sz="2172" b="1" i="0" spc="543">
                 <a:solidFill>
                   <a:srgbClr val="A77A26"/>
                 </a:solidFill>
@@ -3997,11 +3997,11 @@
           <a:p>
             <a:pPr algn="l">
               <a:lnSpc>
-                <a:spcPts val="5051"/>
+                <a:spcPts val="4562"/>
               </a:lnSpc>
             </a:pPr>
             <a:r>
-              <a:rPr sz="4209" b="0" i="1">
+              <a:rPr sz="3802" b="0" i="1">
                 <a:solidFill>
                   <a:srgbClr val="2A1619"/>
                 </a:solidFill>
@@ -4014,11 +4014,11 @@
           <a:p>
             <a:pPr algn="l">
               <a:lnSpc>
-                <a:spcPts val="5051"/>
+                <a:spcPts val="4562"/>
               </a:lnSpc>
             </a:pPr>
             <a:r>
-              <a:rPr sz="4209" b="0" i="1">
+              <a:rPr sz="3802" b="0" i="1">
                 <a:solidFill>
                   <a:srgbClr val="7D1530"/>
                 </a:solidFill>

</xml_diff>

<commit_message>
Centre le contenu de chaque case du pied et harmonise les tailles de texte
Pied en 4 cases au contenu centré, avec une seule échelle : titre 17, texte principal 27,
texte secondaire 19 (téléphone ramené à 34). Bloc QR code + texte centré dans sa case.
Services légèrement agrandis (33/27). Deux versions et PPTX régénérés.

Co-Authored-By: Claude Opus 5.5 <noreply@anthropic.com>
Claude-Session: https://claude.ai/code/session_01MhDWXdDg6yxkfVQXWRp9UB
</commit_message>
<xml_diff>
--- a/panneau/exports/panneau-cave71-A1-clair-modifiable.pptx
+++ b/panneau/exports/panneau-cave71-A1-clair-modifiable.pptx
@@ -3316,8 +3316,8 @@
         </p:nvSpPr>
         <p:spPr>
           <a:xfrm>
-            <a:off x="1207161" y="20935625"/>
-            <a:ext cx="3793935" cy="1090756"/>
+            <a:off x="1207161" y="21004606"/>
+            <a:ext cx="3793935" cy="1189916"/>
           </a:xfrm>
           <a:prstGeom prst="rect">
             <a:avLst/>
@@ -3330,11 +3330,11 @@
           <a:p>
             <a:pPr algn="ctr">
               <a:lnSpc>
-                <a:spcPts val="4684"/>
+                <a:spcPts val="5153"/>
               </a:lnSpc>
             </a:pPr>
             <a:r>
-              <a:rPr sz="4073" b="1" i="0">
+              <a:rPr sz="4481" b="1" i="0">
                 <a:solidFill>
                   <a:srgbClr val="2A1619"/>
                 </a:solidFill>
@@ -3347,11 +3347,11 @@
           <a:p>
             <a:pPr algn="ctr">
               <a:lnSpc>
-                <a:spcPts val="3903"/>
+                <a:spcPts val="4216"/>
               </a:lnSpc>
             </a:pPr>
             <a:r>
-              <a:rPr sz="3394" b="0" i="1">
+              <a:rPr sz="3666" b="0" i="1">
                 <a:solidFill>
                   <a:srgbClr val="7D1530"/>
                 </a:solidFill>
@@ -3371,8 +3371,8 @@
         </p:nvSpPr>
         <p:spPr>
           <a:xfrm>
-            <a:off x="5001096" y="20935625"/>
-            <a:ext cx="3793935" cy="1090756"/>
+            <a:off x="5001096" y="21004606"/>
+            <a:ext cx="3793935" cy="1189916"/>
           </a:xfrm>
           <a:prstGeom prst="rect">
             <a:avLst/>
@@ -3385,11 +3385,11 @@
           <a:p>
             <a:pPr algn="ctr">
               <a:lnSpc>
-                <a:spcPts val="4684"/>
+                <a:spcPts val="5153"/>
               </a:lnSpc>
             </a:pPr>
             <a:r>
-              <a:rPr sz="4073" b="1" i="0">
+              <a:rPr sz="4481" b="1" i="0">
                 <a:solidFill>
                   <a:srgbClr val="2A1619"/>
                 </a:solidFill>
@@ -3402,11 +3402,11 @@
           <a:p>
             <a:pPr algn="ctr">
               <a:lnSpc>
-                <a:spcPts val="3903"/>
+                <a:spcPts val="4216"/>
               </a:lnSpc>
             </a:pPr>
             <a:r>
-              <a:rPr sz="3394" b="0" i="1">
+              <a:rPr sz="3666" b="0" i="1">
                 <a:solidFill>
                   <a:srgbClr val="7D1530"/>
                 </a:solidFill>
@@ -3426,8 +3426,8 @@
         </p:nvSpPr>
         <p:spPr>
           <a:xfrm>
-            <a:off x="8795032" y="20935625"/>
-            <a:ext cx="3793935" cy="1090756"/>
+            <a:off x="8795032" y="21004606"/>
+            <a:ext cx="3793935" cy="1189916"/>
           </a:xfrm>
           <a:prstGeom prst="rect">
             <a:avLst/>
@@ -3440,11 +3440,11 @@
           <a:p>
             <a:pPr algn="ctr">
               <a:lnSpc>
-                <a:spcPts val="4684"/>
+                <a:spcPts val="5153"/>
               </a:lnSpc>
             </a:pPr>
             <a:r>
-              <a:rPr sz="4073" b="1" i="0">
+              <a:rPr sz="4481" b="1" i="0">
                 <a:solidFill>
                   <a:srgbClr val="2A1619"/>
                 </a:solidFill>
@@ -3457,11 +3457,11 @@
           <a:p>
             <a:pPr algn="ctr">
               <a:lnSpc>
-                <a:spcPts val="3903"/>
+                <a:spcPts val="4216"/>
               </a:lnSpc>
             </a:pPr>
             <a:r>
-              <a:rPr sz="3394" b="0" i="1">
+              <a:rPr sz="3666" b="0" i="1">
                 <a:solidFill>
                   <a:srgbClr val="7D1530"/>
                 </a:solidFill>
@@ -3481,8 +3481,8 @@
         </p:nvSpPr>
         <p:spPr>
           <a:xfrm>
-            <a:off x="12588967" y="20935625"/>
-            <a:ext cx="3793935" cy="1090756"/>
+            <a:off x="12588967" y="21004606"/>
+            <a:ext cx="3793935" cy="1189916"/>
           </a:xfrm>
           <a:prstGeom prst="rect">
             <a:avLst/>
@@ -3495,11 +3495,11 @@
           <a:p>
             <a:pPr algn="ctr">
               <a:lnSpc>
-                <a:spcPts val="4684"/>
+                <a:spcPts val="5153"/>
               </a:lnSpc>
             </a:pPr>
             <a:r>
-              <a:rPr sz="4073" b="1" i="0">
+              <a:rPr sz="4481" b="1" i="0">
                 <a:solidFill>
                   <a:srgbClr val="2A1619"/>
                 </a:solidFill>
@@ -3512,11 +3512,11 @@
           <a:p>
             <a:pPr algn="ctr">
               <a:lnSpc>
-                <a:spcPts val="3903"/>
+                <a:spcPts val="4216"/>
               </a:lnSpc>
             </a:pPr>
             <a:r>
-              <a:rPr sz="3394" b="0" i="1">
+              <a:rPr sz="3666" b="0" i="1">
                 <a:solidFill>
                   <a:srgbClr val="7D1530"/>
                 </a:solidFill>
@@ -3536,8 +3536,8 @@
         </p:nvSpPr>
         <p:spPr>
           <a:xfrm>
-            <a:off x="16382903" y="20935625"/>
-            <a:ext cx="3793935" cy="1090756"/>
+            <a:off x="16382903" y="21004606"/>
+            <a:ext cx="3793935" cy="1189916"/>
           </a:xfrm>
           <a:prstGeom prst="rect">
             <a:avLst/>
@@ -3550,11 +3550,11 @@
           <a:p>
             <a:pPr algn="ctr">
               <a:lnSpc>
-                <a:spcPts val="4684"/>
+                <a:spcPts val="5153"/>
               </a:lnSpc>
             </a:pPr>
             <a:r>
-              <a:rPr sz="4073" b="1" i="0">
+              <a:rPr sz="4481" b="1" i="0">
                 <a:solidFill>
                   <a:srgbClr val="2A1619"/>
                 </a:solidFill>
@@ -3567,11 +3567,11 @@
           <a:p>
             <a:pPr algn="ctr">
               <a:lnSpc>
-                <a:spcPts val="3903"/>
+                <a:spcPts val="4216"/>
               </a:lnSpc>
             </a:pPr>
             <a:r>
-              <a:rPr sz="3394" b="0" i="1">
+              <a:rPr sz="3666" b="0" i="1">
                 <a:solidFill>
                   <a:srgbClr val="7D1530"/>
                 </a:solidFill>
@@ -3591,100 +3591,7 @@
         </p:nvSpPr>
         <p:spPr>
           <a:xfrm>
-            <a:off x="1207161" y="23384438"/>
-            <a:ext cx="9312387" cy="331107"/>
-          </a:xfrm>
-          <a:prstGeom prst="rect">
-            <a:avLst/>
-          </a:prstGeom>
-          <a:noFill/>
-        </p:spPr>
-        <p:txBody>
-          <a:bodyPr wrap="none" anchor="t" lIns="0" rIns="0" tIns="0" bIns="0"/>
-          <a:lstStyle/>
-          <a:p>
-            <a:pPr algn="l">
-              <a:lnSpc>
-                <a:spcPts val="2607"/>
-              </a:lnSpc>
-            </a:pPr>
-            <a:r>
-              <a:rPr sz="2172" b="1" i="0" spc="543">
-                <a:solidFill>
-                  <a:srgbClr val="A77A26"/>
-                </a:solidFill>
-                <a:latin typeface="Montserrat"/>
-                <a:cs typeface="Montserrat"/>
-              </a:rPr>
-              <a:t>NOUS TROUVER</a:t>
-            </a:r>
-          </a:p>
-        </p:txBody>
-      </p:sp>
-      <p:sp>
-        <p:nvSpPr>
-          <p:cNvPr id="14" name="adresse"/>
-          <p:cNvSpPr txBox="1"/>
-          <p:nvPr/>
-        </p:nvSpPr>
-        <p:spPr>
-          <a:xfrm>
-            <a:off x="1207161" y="23867303"/>
-            <a:ext cx="9312387" cy="1164048"/>
-          </a:xfrm>
-          <a:prstGeom prst="rect">
-            <a:avLst/>
-          </a:prstGeom>
-          <a:noFill/>
-        </p:spPr>
-        <p:txBody>
-          <a:bodyPr wrap="none" anchor="t" lIns="0" rIns="0" tIns="0" bIns="0"/>
-          <a:lstStyle/>
-          <a:p>
-            <a:pPr algn="l">
-              <a:lnSpc>
-                <a:spcPts val="4582"/>
-              </a:lnSpc>
-            </a:pPr>
-            <a:r>
-              <a:rPr sz="3666" b="0" i="0">
-                <a:solidFill>
-                  <a:srgbClr val="2A1619"/>
-                </a:solidFill>
-                <a:latin typeface="Montserrat"/>
-                <a:cs typeface="Montserrat"/>
-              </a:rPr>
-              <a:t>71 avenue de la Libération</a:t>
-            </a:r>
-          </a:p>
-          <a:p>
-            <a:pPr algn="l">
-              <a:lnSpc>
-                <a:spcPts val="4582"/>
-              </a:lnSpc>
-            </a:pPr>
-            <a:r>
-              <a:rPr sz="3666" b="0" i="0">
-                <a:solidFill>
-                  <a:srgbClr val="2A1619"/>
-                </a:solidFill>
-                <a:latin typeface="Montserrat"/>
-                <a:cs typeface="Montserrat"/>
-              </a:rPr>
-              <a:t>44400 Rezé</a:t>
-            </a:r>
-          </a:p>
-        </p:txBody>
-      </p:sp>
-      <p:sp>
-        <p:nvSpPr>
-          <p:cNvPr id="15" name="adresse-precision"/>
-          <p:cNvSpPr txBox="1"/>
-          <p:nvPr/>
-        </p:nvSpPr>
-        <p:spPr>
-          <a:xfrm>
-            <a:off x="1207161" y="25212425"/>
+            <a:off x="1293387" y="23625870"/>
             <a:ext cx="9312387" cy="351801"/>
           </a:xfrm>
           <a:prstGeom prst="rect">
@@ -3696,34 +3603,34 @@
           <a:bodyPr wrap="none" anchor="t" lIns="0" rIns="0" tIns="0" bIns="0"/>
           <a:lstStyle/>
           <a:p>
-            <a:pPr algn="l">
+            <a:pPr algn="ctr">
               <a:lnSpc>
                 <a:spcPts val="2770"/>
               </a:lnSpc>
             </a:pPr>
             <a:r>
-              <a:rPr sz="2308" b="0" i="0">
-                <a:solidFill>
-                  <a:srgbClr val="7D1530"/>
+              <a:rPr sz="2308" b="1" i="0" spc="543">
+                <a:solidFill>
+                  <a:srgbClr val="A77A26"/>
                 </a:solidFill>
                 <a:latin typeface="Montserrat"/>
                 <a:cs typeface="Montserrat"/>
               </a:rPr>
-              <a:t>En face du parking et du tram du 8 Mai</a:t>
-            </a:r>
-          </a:p>
-        </p:txBody>
-      </p:sp>
-      <p:sp>
-        <p:nvSpPr>
-          <p:cNvPr id="16" name="horaires-titre"/>
+              <a:t>NOUS TROUVER</a:t>
+            </a:r>
+          </a:p>
+        </p:txBody>
+      </p:sp>
+      <p:sp>
+        <p:nvSpPr>
+          <p:cNvPr id="14" name="adresse"/>
           <p:cNvSpPr txBox="1"/>
           <p:nvPr/>
         </p:nvSpPr>
         <p:spPr>
           <a:xfrm>
-            <a:off x="11468032" y="23384438"/>
-            <a:ext cx="8795032" cy="331107"/>
+            <a:off x="1293387" y="24143225"/>
+            <a:ext cx="9312387" cy="1210610"/>
           </a:xfrm>
           <a:prstGeom prst="rect">
             <a:avLst/>
@@ -3734,34 +3641,51 @@
           <a:bodyPr wrap="none" anchor="t" lIns="0" rIns="0" tIns="0" bIns="0"/>
           <a:lstStyle/>
           <a:p>
-            <a:pPr algn="l">
+            <a:pPr algn="ctr">
               <a:lnSpc>
-                <a:spcPts val="2607"/>
+                <a:spcPts val="4766"/>
               </a:lnSpc>
             </a:pPr>
             <a:r>
-              <a:rPr sz="2172" b="1" i="0" spc="543">
-                <a:solidFill>
-                  <a:srgbClr val="A77A26"/>
+              <a:rPr sz="3666" b="0" i="0">
+                <a:solidFill>
+                  <a:srgbClr val="2A1619"/>
                 </a:solidFill>
                 <a:latin typeface="Montserrat"/>
                 <a:cs typeface="Montserrat"/>
               </a:rPr>
-              <a:t>DU MARDI AU SAMEDI</a:t>
-            </a:r>
-          </a:p>
-        </p:txBody>
-      </p:sp>
-      <p:sp>
-        <p:nvSpPr>
-          <p:cNvPr id="17" name="horaires"/>
+              <a:t>71 avenue de la Libération</a:t>
+            </a:r>
+          </a:p>
+          <a:p>
+            <a:pPr algn="ctr">
+              <a:lnSpc>
+                <a:spcPts val="4766"/>
+              </a:lnSpc>
+            </a:pPr>
+            <a:r>
+              <a:rPr sz="3666" b="0" i="0">
+                <a:solidFill>
+                  <a:srgbClr val="2A1619"/>
+                </a:solidFill>
+                <a:latin typeface="Montserrat"/>
+                <a:cs typeface="Montserrat"/>
+              </a:rPr>
+              <a:t>44400 Rezé</a:t>
+            </a:r>
+          </a:p>
+        </p:txBody>
+      </p:sp>
+      <p:sp>
+        <p:nvSpPr>
+          <p:cNvPr id="15" name="adresse-precision"/>
           <p:cNvSpPr txBox="1"/>
           <p:nvPr/>
         </p:nvSpPr>
         <p:spPr>
           <a:xfrm>
-            <a:off x="11468032" y="23867303"/>
-            <a:ext cx="8795032" cy="558743"/>
+            <a:off x="1293387" y="25419367"/>
+            <a:ext cx="9312387" cy="393189"/>
           </a:xfrm>
           <a:prstGeom prst="rect">
             <a:avLst/>
@@ -3772,54 +3696,34 @@
           <a:bodyPr wrap="none" anchor="t" lIns="0" rIns="0" tIns="0" bIns="0"/>
           <a:lstStyle/>
           <a:p>
-            <a:pPr algn="l">
+            <a:pPr algn="ctr">
               <a:lnSpc>
-                <a:spcPts val="4399"/>
+                <a:spcPts val="3095"/>
               </a:lnSpc>
             </a:pPr>
             <a:r>
-              <a:rPr sz="3666" b="0" i="0">
-                <a:solidFill>
-                  <a:srgbClr val="2A1619"/>
+              <a:rPr sz="2579" b="0" i="0">
+                <a:solidFill>
+                  <a:srgbClr val="7D1530"/>
                 </a:solidFill>
                 <a:latin typeface="Montserrat"/>
                 <a:cs typeface="Montserrat"/>
               </a:rPr>
-              <a:t>10h – 13h </a:t>
-            </a:r>
-            <a:r>
-              <a:rPr sz="3666" b="0" i="0">
-                <a:solidFill>
-                  <a:srgbClr val="A77A26"/>
-                </a:solidFill>
-                <a:latin typeface="Montserrat"/>
-                <a:cs typeface="Montserrat"/>
-              </a:rPr>
-              <a:t>·</a:t>
-            </a:r>
-            <a:r>
-              <a:rPr sz="3666" b="0" i="0">
-                <a:solidFill>
-                  <a:srgbClr val="2A1619"/>
-                </a:solidFill>
-                <a:latin typeface="Montserrat"/>
-                <a:cs typeface="Montserrat"/>
-              </a:rPr>
-              <a:t> 15h30 – 19h30</a:t>
-            </a:r>
-          </a:p>
-        </p:txBody>
-      </p:sp>
-      <p:sp>
-        <p:nvSpPr>
-          <p:cNvPr id="18" name="telephone"/>
+              <a:t>En face du parking et du tram du 8 Mai</a:t>
+            </a:r>
+          </a:p>
+        </p:txBody>
+      </p:sp>
+      <p:sp>
+        <p:nvSpPr>
+          <p:cNvPr id="16" name="horaires-titre"/>
           <p:cNvSpPr txBox="1"/>
           <p:nvPr/>
         </p:nvSpPr>
         <p:spPr>
           <a:xfrm>
-            <a:off x="11468032" y="24557109"/>
-            <a:ext cx="8795032" cy="910544"/>
+            <a:off x="11381806" y="23625870"/>
+            <a:ext cx="8622580" cy="351801"/>
           </a:xfrm>
           <a:prstGeom prst="rect">
             <a:avLst/>
@@ -3830,34 +3734,34 @@
           <a:bodyPr wrap="none" anchor="t" lIns="0" rIns="0" tIns="0" bIns="0"/>
           <a:lstStyle/>
           <a:p>
-            <a:pPr algn="l">
+            <a:pPr algn="ctr">
               <a:lnSpc>
-                <a:spcPts val="7169"/>
+                <a:spcPts val="2770"/>
               </a:lnSpc>
             </a:pPr>
             <a:r>
-              <a:rPr sz="5974" b="1" i="0" spc="204">
-                <a:solidFill>
-                  <a:srgbClr val="2A1619"/>
+              <a:rPr sz="2308" b="1" i="0" spc="543">
+                <a:solidFill>
+                  <a:srgbClr val="A77A26"/>
                 </a:solidFill>
                 <a:latin typeface="Montserrat"/>
                 <a:cs typeface="Montserrat"/>
               </a:rPr>
-              <a:t>02 49 62 66 45</a:t>
-            </a:r>
-          </a:p>
-        </p:txBody>
-      </p:sp>
-      <p:sp>
-        <p:nvSpPr>
-          <p:cNvPr id="19" name="en-ligne-titre"/>
+              <a:t>DU MARDI AU SAMEDI</a:t>
+            </a:r>
+          </a:p>
+        </p:txBody>
+      </p:sp>
+      <p:sp>
+        <p:nvSpPr>
+          <p:cNvPr id="17" name="horaires"/>
           <p:cNvSpPr txBox="1"/>
           <p:nvPr/>
         </p:nvSpPr>
         <p:spPr>
           <a:xfrm>
-            <a:off x="1207161" y="26316116"/>
-            <a:ext cx="9312387" cy="331107"/>
+            <a:off x="11381806" y="24143225"/>
+            <a:ext cx="8622580" cy="558743"/>
           </a:xfrm>
           <a:prstGeom prst="rect">
             <a:avLst/>
@@ -3868,34 +3772,54 @@
           <a:bodyPr wrap="none" anchor="t" lIns="0" rIns="0" tIns="0" bIns="0"/>
           <a:lstStyle/>
           <a:p>
-            <a:pPr algn="l">
+            <a:pPr algn="ctr">
               <a:lnSpc>
-                <a:spcPts val="2607"/>
+                <a:spcPts val="4399"/>
               </a:lnSpc>
             </a:pPr>
             <a:r>
-              <a:rPr sz="2172" b="1" i="0" spc="543">
-                <a:solidFill>
-                  <a:srgbClr val="A77A26"/>
+              <a:rPr sz="3666" b="0" i="0">
+                <a:solidFill>
+                  <a:srgbClr val="2A1619"/>
                 </a:solidFill>
                 <a:latin typeface="Montserrat"/>
                 <a:cs typeface="Montserrat"/>
               </a:rPr>
-              <a:t>EN LIGNE</a:t>
-            </a:r>
-          </a:p>
-        </p:txBody>
-      </p:sp>
-      <p:sp>
-        <p:nvSpPr>
-          <p:cNvPr id="20" name="en-ligne"/>
+              <a:t>10h – 13h  </a:t>
+            </a:r>
+            <a:r>
+              <a:rPr sz="3666" b="0" i="0">
+                <a:solidFill>
+                  <a:srgbClr val="A77A26"/>
+                </a:solidFill>
+                <a:latin typeface="Montserrat"/>
+                <a:cs typeface="Montserrat"/>
+              </a:rPr>
+              <a:t>·</a:t>
+            </a:r>
+            <a:r>
+              <a:rPr sz="3666" b="0" i="0">
+                <a:solidFill>
+                  <a:srgbClr val="2A1619"/>
+                </a:solidFill>
+                <a:latin typeface="Montserrat"/>
+                <a:cs typeface="Montserrat"/>
+              </a:rPr>
+              <a:t>  15h30 – 19h30</a:t>
+            </a:r>
+          </a:p>
+        </p:txBody>
+      </p:sp>
+      <p:sp>
+        <p:nvSpPr>
+          <p:cNvPr id="18" name="telephone"/>
           <p:cNvSpPr txBox="1"/>
           <p:nvPr/>
         </p:nvSpPr>
         <p:spPr>
           <a:xfrm>
-            <a:off x="1207161" y="26798980"/>
-            <a:ext cx="9312387" cy="1496880"/>
+            <a:off x="11381806" y="24833032"/>
+            <a:ext cx="8622580" cy="703602"/>
           </a:xfrm>
           <a:prstGeom prst="rect">
             <a:avLst/>
@@ -3906,68 +3830,34 @@
           <a:bodyPr wrap="none" anchor="t" lIns="0" rIns="0" tIns="0" bIns="0"/>
           <a:lstStyle/>
           <a:p>
-            <a:pPr algn="l">
+            <a:pPr algn="ctr">
               <a:lnSpc>
-                <a:spcPts val="4942"/>
+                <a:spcPts val="5540"/>
               </a:lnSpc>
             </a:pPr>
             <a:r>
-              <a:rPr sz="3530" b="0" i="0">
+              <a:rPr sz="4616" b="1" i="0" spc="204">
                 <a:solidFill>
                   <a:srgbClr val="2A1619"/>
                 </a:solidFill>
                 <a:latin typeface="Montserrat"/>
                 <a:cs typeface="Montserrat"/>
               </a:rPr>
-              <a:t>cave71.com</a:t>
-            </a:r>
-          </a:p>
-          <a:p>
-            <a:pPr algn="l">
-              <a:lnSpc>
-                <a:spcPts val="3421"/>
-              </a:lnSpc>
-            </a:pPr>
-            <a:r>
-              <a:rPr sz="2444" b="0" i="0">
-                <a:solidFill>
-                  <a:srgbClr val="5E4E4D"/>
-                </a:solidFill>
-                <a:latin typeface="Montserrat"/>
-                <a:cs typeface="Montserrat"/>
-              </a:rPr>
-              <a:t>contact.cave71@gmail.com</a:t>
-            </a:r>
-          </a:p>
-          <a:p>
-            <a:pPr algn="l">
-              <a:lnSpc>
-                <a:spcPts val="3421"/>
-              </a:lnSpc>
-            </a:pPr>
-            <a:r>
-              <a:rPr sz="2444" b="0" i="0">
-                <a:solidFill>
-                  <a:srgbClr val="5E4E4D"/>
-                </a:solidFill>
-                <a:latin typeface="Montserrat"/>
-                <a:cs typeface="Montserrat"/>
-              </a:rPr>
-              <a:t>Facebook : Cave 71</a:t>
-            </a:r>
-          </a:p>
-        </p:txBody>
-      </p:sp>
-      <p:sp>
-        <p:nvSpPr>
-          <p:cNvPr id="21" name="qr-texte"/>
+              <a:t>02 49 62 66 45</a:t>
+            </a:r>
+          </a:p>
+        </p:txBody>
+      </p:sp>
+      <p:sp>
+        <p:nvSpPr>
+          <p:cNvPr id="19" name="en-ligne-titre"/>
           <p:cNvSpPr txBox="1"/>
           <p:nvPr/>
         </p:nvSpPr>
         <p:spPr>
           <a:xfrm>
-            <a:off x="14175522" y="26454077"/>
-            <a:ext cx="6035806" cy="1489981"/>
+            <a:off x="1293387" y="26454077"/>
+            <a:ext cx="9312387" cy="351801"/>
           </a:xfrm>
           <a:prstGeom prst="rect">
             <a:avLst/>
@@ -3978,13 +3868,123 @@
           <a:bodyPr wrap="none" anchor="t" lIns="0" rIns="0" tIns="0" bIns="0"/>
           <a:lstStyle/>
           <a:p>
+            <a:pPr algn="ctr">
+              <a:lnSpc>
+                <a:spcPts val="2770"/>
+              </a:lnSpc>
+            </a:pPr>
+            <a:r>
+              <a:rPr sz="2308" b="1" i="0" spc="543">
+                <a:solidFill>
+                  <a:srgbClr val="A77A26"/>
+                </a:solidFill>
+                <a:latin typeface="Montserrat"/>
+                <a:cs typeface="Montserrat"/>
+              </a:rPr>
+              <a:t>EN LIGNE</a:t>
+            </a:r>
+          </a:p>
+        </p:txBody>
+      </p:sp>
+      <p:sp>
+        <p:nvSpPr>
+          <p:cNvPr id="20" name="en-ligne"/>
+          <p:cNvSpPr txBox="1"/>
+          <p:nvPr/>
+        </p:nvSpPr>
+        <p:spPr>
+          <a:xfrm>
+            <a:off x="1293387" y="26971432"/>
+            <a:ext cx="9312387" cy="1513262"/>
+          </a:xfrm>
+          <a:prstGeom prst="rect">
+            <a:avLst/>
+          </a:prstGeom>
+          <a:noFill/>
+        </p:spPr>
+        <p:txBody>
+          <a:bodyPr wrap="none" anchor="t" lIns="0" rIns="0" tIns="0" bIns="0"/>
+          <a:lstStyle/>
+          <a:p>
+            <a:pPr algn="ctr">
+              <a:lnSpc>
+                <a:spcPts val="4949"/>
+              </a:lnSpc>
+            </a:pPr>
+            <a:r>
+              <a:rPr sz="3666" b="0" i="0">
+                <a:solidFill>
+                  <a:srgbClr val="2A1619"/>
+                </a:solidFill>
+                <a:latin typeface="Montserrat"/>
+                <a:cs typeface="Montserrat"/>
+              </a:rPr>
+              <a:t>cave71.com</a:t>
+            </a:r>
+          </a:p>
+          <a:p>
+            <a:pPr algn="ctr">
+              <a:lnSpc>
+                <a:spcPts val="3482"/>
+              </a:lnSpc>
+            </a:pPr>
+            <a:r>
+              <a:rPr sz="2579" b="0" i="0">
+                <a:solidFill>
+                  <a:srgbClr val="7D1530"/>
+                </a:solidFill>
+                <a:latin typeface="Montserrat"/>
+                <a:cs typeface="Montserrat"/>
+              </a:rPr>
+              <a:t>contact.cave71@gmail.com</a:t>
+            </a:r>
+          </a:p>
+          <a:p>
+            <a:pPr algn="ctr">
+              <a:lnSpc>
+                <a:spcPts val="3482"/>
+              </a:lnSpc>
+            </a:pPr>
+            <a:r>
+              <a:rPr sz="2579" b="0" i="0">
+                <a:solidFill>
+                  <a:srgbClr val="7D1530"/>
+                </a:solidFill>
+                <a:latin typeface="Montserrat"/>
+                <a:cs typeface="Montserrat"/>
+              </a:rPr>
+              <a:t>Facebook : Cave 71</a:t>
+            </a:r>
+          </a:p>
+        </p:txBody>
+      </p:sp>
+      <p:sp>
+        <p:nvSpPr>
+          <p:cNvPr id="21" name="qr-texte"/>
+          <p:cNvSpPr txBox="1"/>
+          <p:nvPr/>
+        </p:nvSpPr>
+        <p:spPr>
+          <a:xfrm>
+            <a:off x="14692877" y="26661019"/>
+            <a:ext cx="5518451" cy="1575345"/>
+          </a:xfrm>
+          <a:prstGeom prst="rect">
+            <a:avLst/>
+          </a:prstGeom>
+          <a:noFill/>
+        </p:spPr>
+        <p:txBody>
+          <a:bodyPr wrap="none" anchor="t" lIns="0" rIns="0" tIns="0" bIns="0"/>
+          <a:lstStyle/>
+          <a:p>
             <a:pPr algn="l">
               <a:lnSpc>
-                <a:spcPts val="2607"/>
+                <a:spcPts val="3347"/>
               </a:lnSpc>
             </a:pPr>
             <a:r>
-              <a:rPr sz="2172" b="1" i="0" spc="543">
+              <a:rPr sz="2308" b="1" i="0" spc="543">
                 <a:solidFill>
                   <a:srgbClr val="A77A26"/>
                 </a:solidFill>
@@ -3997,16 +3997,16 @@
           <a:p>
             <a:pPr algn="l">
               <a:lnSpc>
-                <a:spcPts val="4562"/>
+                <a:spcPts val="5316"/>
               </a:lnSpc>
             </a:pPr>
             <a:r>
-              <a:rPr sz="3802" b="0" i="1">
+              <a:rPr sz="3666" b="0" i="0">
                 <a:solidFill>
                   <a:srgbClr val="2A1619"/>
                 </a:solidFill>
-                <a:latin typeface="Cormorant Garamond"/>
-                <a:cs typeface="Cormorant Garamond"/>
+                <a:latin typeface="Montserrat"/>
+                <a:cs typeface="Montserrat"/>
               </a:rPr>
               <a:t>Découvrez nos vins</a:t>
             </a:r>
@@ -4014,16 +4014,16 @@
           <a:p>
             <a:pPr algn="l">
               <a:lnSpc>
-                <a:spcPts val="4562"/>
+                <a:spcPts val="3740"/>
               </a:lnSpc>
             </a:pPr>
             <a:r>
-              <a:rPr sz="3802" b="0" i="1">
+              <a:rPr sz="2579" b="0" i="0">
                 <a:solidFill>
                   <a:srgbClr val="7D1530"/>
                 </a:solidFill>
-                <a:latin typeface="Cormorant Garamond"/>
-                <a:cs typeface="Cormorant Garamond"/>
+                <a:latin typeface="Montserrat"/>
+                <a:cs typeface="Montserrat"/>
               </a:rPr>
               <a:t>&amp; commandez en ligne</a:t>
             </a:r>

</xml_diff>

<commit_message>
Retire les horaires et « commandez en ligne », prépare la bière Lutgarde et le tartinable de courgettes
- Pied : « Du mardi au samedi » + téléphone, et QR code « Découvrez nos vins », recentrés.
- Photos de référence de la bière Lutgarde Blonde et du tartinable L'Atelier d'Émile,
  et prompt Gemini pour remplacer Balac, Divin et la terrine Poissons de Loire.

Co-Authored-By: Claude Opus 5.5 <noreply@anthropic.com>
Claude-Session: https://claude.ai/code/session_01MhDWXdDg6yxkfVQXWRp9UB
</commit_message>
<xml_diff>
--- a/panneau/exports/panneau-cave71-A1-clair-modifiable.pptx
+++ b/panneau/exports/panneau-cave71-A1-clair-modifiable.pptx
@@ -3722,7 +3722,7 @@
         </p:nvSpPr>
         <p:spPr>
           <a:xfrm>
-            <a:off x="11381806" y="23625870"/>
+            <a:off x="11381806" y="24005264"/>
             <a:ext cx="8622580" cy="351801"/>
           </a:xfrm>
           <a:prstGeom prst="rect">
@@ -3754,71 +3754,13 @@
       </p:sp>
       <p:sp>
         <p:nvSpPr>
-          <p:cNvPr id="17" name="horaires"/>
+          <p:cNvPr id="17" name="telephone"/>
           <p:cNvSpPr txBox="1"/>
           <p:nvPr/>
         </p:nvSpPr>
         <p:spPr>
           <a:xfrm>
-            <a:off x="11381806" y="24143225"/>
-            <a:ext cx="8622580" cy="558743"/>
-          </a:xfrm>
-          <a:prstGeom prst="rect">
-            <a:avLst/>
-          </a:prstGeom>
-          <a:noFill/>
-        </p:spPr>
-        <p:txBody>
-          <a:bodyPr wrap="none" anchor="t" lIns="0" rIns="0" tIns="0" bIns="0"/>
-          <a:lstStyle/>
-          <a:p>
-            <a:pPr algn="ctr">
-              <a:lnSpc>
-                <a:spcPts val="4399"/>
-              </a:lnSpc>
-            </a:pPr>
-            <a:r>
-              <a:rPr sz="3666" b="0" i="0">
-                <a:solidFill>
-                  <a:srgbClr val="2A1619"/>
-                </a:solidFill>
-                <a:latin typeface="Montserrat"/>
-                <a:cs typeface="Montserrat"/>
-              </a:rPr>
-              <a:t>10h – 13h  </a:t>
-            </a:r>
-            <a:r>
-              <a:rPr sz="3666" b="0" i="0">
-                <a:solidFill>
-                  <a:srgbClr val="A77A26"/>
-                </a:solidFill>
-                <a:latin typeface="Montserrat"/>
-                <a:cs typeface="Montserrat"/>
-              </a:rPr>
-              <a:t>·</a:t>
-            </a:r>
-            <a:r>
-              <a:rPr sz="3666" b="0" i="0">
-                <a:solidFill>
-                  <a:srgbClr val="2A1619"/>
-                </a:solidFill>
-                <a:latin typeface="Montserrat"/>
-                <a:cs typeface="Montserrat"/>
-              </a:rPr>
-              <a:t>  15h30 – 19h30</a:t>
-            </a:r>
-          </a:p>
-        </p:txBody>
-      </p:sp>
-      <p:sp>
-        <p:nvSpPr>
-          <p:cNvPr id="18" name="telephone"/>
-          <p:cNvSpPr txBox="1"/>
-          <p:nvPr/>
-        </p:nvSpPr>
-        <p:spPr>
-          <a:xfrm>
-            <a:off x="11381806" y="24833032"/>
+            <a:off x="11381806" y="24488129"/>
             <a:ext cx="8622580" cy="703602"/>
           </a:xfrm>
           <a:prstGeom prst="rect">
@@ -3850,7 +3792,7 @@
       </p:sp>
       <p:sp>
         <p:nvSpPr>
-          <p:cNvPr id="19" name="en-ligne-titre"/>
+          <p:cNvPr id="18" name="en-ligne-titre"/>
           <p:cNvSpPr txBox="1"/>
           <p:nvPr/>
         </p:nvSpPr>
@@ -3888,7 +3830,7 @@
       </p:sp>
       <p:sp>
         <p:nvSpPr>
-          <p:cNvPr id="20" name="en-ligne"/>
+          <p:cNvPr id="19" name="en-ligne"/>
           <p:cNvSpPr txBox="1"/>
           <p:nvPr/>
         </p:nvSpPr>
@@ -3960,14 +3902,14 @@
       </p:sp>
       <p:sp>
         <p:nvSpPr>
-          <p:cNvPr id="21" name="qr-texte"/>
+          <p:cNvPr id="20" name="qr-texte"/>
           <p:cNvSpPr txBox="1"/>
           <p:nvPr/>
         </p:nvSpPr>
         <p:spPr>
           <a:xfrm>
-            <a:off x="14692877" y="26661019"/>
-            <a:ext cx="5518451" cy="1575345"/>
+            <a:off x="14692877" y="26902451"/>
+            <a:ext cx="5518451" cy="1100241"/>
           </a:xfrm>
           <a:prstGeom prst="rect">
             <a:avLst/>
@@ -4011,28 +3953,11 @@
               <a:t>Découvrez nos vins</a:t>
             </a:r>
           </a:p>
-          <a:p>
-            <a:pPr algn="l">
-              <a:lnSpc>
-                <a:spcPts val="3740"/>
-              </a:lnSpc>
-            </a:pPr>
-            <a:r>
-              <a:rPr sz="2579" b="0" i="0">
-                <a:solidFill>
-                  <a:srgbClr val="7D1530"/>
-                </a:solidFill>
-                <a:latin typeface="Montserrat"/>
-                <a:cs typeface="Montserrat"/>
-              </a:rPr>
-              <a:t>&amp; commandez en ligne</a:t>
-            </a:r>
-          </a:p>
-        </p:txBody>
-      </p:sp>
-      <p:sp>
-        <p:nvSpPr>
-          <p:cNvPr id="22" name="mention-legale"/>
+        </p:txBody>
+      </p:sp>
+      <p:sp>
+        <p:nvSpPr>
+          <p:cNvPr id="21" name="mention-legale"/>
           <p:cNvSpPr txBox="1"/>
           <p:nvPr/>
         </p:nvSpPr>

</xml_diff>